<commit_message>
Refine repo setup, notebooks, class project intro and slides
- Merge setup instructions into README (kernel selection step, troubleshooting)
- Rename datathon brief to data_science_bootcamp_lecture_1_class_project_intro.md,
  clarify claim fields/exposure, link the refreshed data dictionary
- Notebook 1: create .local and skip existing downloads; link intro in all notebooks
- Notebook 2: fix duplicated columns in correlation heatmap, add Mermaid flowchart,
  auto-insurance VarClusHi example
- Notebook 3: copy slices to avoid SettingWithCopyWarning
- Notebook 4: rank predictors by model gain importance, save predictiveness plots to PDF
- Helpers: optional pdf_path in PredictivenessCheckList.plot_all
- Slides: wording pass, expanded weather/credit examples on slide 5; keep 2025 original in archive/
- Add CLAUDE.md, ignore caches/.DS_Store/.docs/.data, untrack .pyc files

Co-Authored-By: Claude Sonnet 5.5 <noreply@anthropic.com>
</commit_message>
<xml_diff>
--- a/data_science_bootcamp_lecture_1_slides.pptx
+++ b/data_science_bootcamp_lecture_1_slides.pptx
@@ -207,7 +207,7 @@
           <a:p>
             <a:fld id="{4EBF85B4-A467-4B5C-B35B-A3E2A8841D96}" type="datetimeFigureOut">
               <a:rPr lang="en-US" smtClean="0"/>
-              <a:t>10/13/2025</a:t>
+              <a:t>10/4/26</a:t>
             </a:fld>
             <a:endParaRPr lang="en-US"/>
           </a:p>
@@ -914,7 +914,7 @@
           <a:p>
             <a:fld id="{ACF36A98-F08A-4CFD-BE0D-05F2CBB67E88}" type="datetimeFigureOut">
               <a:rPr lang="en-US" smtClean="0"/>
-              <a:t>10/13/2025</a:t>
+              <a:t>10/4/26</a:t>
             </a:fld>
             <a:endParaRPr lang="en-US"/>
           </a:p>
@@ -1084,7 +1084,7 @@
           <a:p>
             <a:fld id="{ACF36A98-F08A-4CFD-BE0D-05F2CBB67E88}" type="datetimeFigureOut">
               <a:rPr lang="en-US" smtClean="0"/>
-              <a:t>10/13/2025</a:t>
+              <a:t>10/4/26</a:t>
             </a:fld>
             <a:endParaRPr lang="en-US"/>
           </a:p>
@@ -1264,7 +1264,7 @@
           <a:p>
             <a:fld id="{ACF36A98-F08A-4CFD-BE0D-05F2CBB67E88}" type="datetimeFigureOut">
               <a:rPr lang="en-US" smtClean="0"/>
-              <a:t>10/13/2025</a:t>
+              <a:t>10/4/26</a:t>
             </a:fld>
             <a:endParaRPr lang="en-US"/>
           </a:p>
@@ -1434,7 +1434,7 @@
           <a:p>
             <a:fld id="{ACF36A98-F08A-4CFD-BE0D-05F2CBB67E88}" type="datetimeFigureOut">
               <a:rPr lang="en-US" smtClean="0"/>
-              <a:t>10/13/2025</a:t>
+              <a:t>10/4/26</a:t>
             </a:fld>
             <a:endParaRPr lang="en-US"/>
           </a:p>
@@ -1680,7 +1680,7 @@
           <a:p>
             <a:fld id="{ACF36A98-F08A-4CFD-BE0D-05F2CBB67E88}" type="datetimeFigureOut">
               <a:rPr lang="en-US" smtClean="0"/>
-              <a:t>10/13/2025</a:t>
+              <a:t>10/4/26</a:t>
             </a:fld>
             <a:endParaRPr lang="en-US"/>
           </a:p>
@@ -1912,7 +1912,7 @@
           <a:p>
             <a:fld id="{ACF36A98-F08A-4CFD-BE0D-05F2CBB67E88}" type="datetimeFigureOut">
               <a:rPr lang="en-US" smtClean="0"/>
-              <a:t>10/13/2025</a:t>
+              <a:t>10/4/26</a:t>
             </a:fld>
             <a:endParaRPr lang="en-US"/>
           </a:p>
@@ -2279,7 +2279,7 @@
           <a:p>
             <a:fld id="{ACF36A98-F08A-4CFD-BE0D-05F2CBB67E88}" type="datetimeFigureOut">
               <a:rPr lang="en-US" smtClean="0"/>
-              <a:t>10/13/2025</a:t>
+              <a:t>10/4/26</a:t>
             </a:fld>
             <a:endParaRPr lang="en-US"/>
           </a:p>
@@ -2397,7 +2397,7 @@
           <a:p>
             <a:fld id="{ACF36A98-F08A-4CFD-BE0D-05F2CBB67E88}" type="datetimeFigureOut">
               <a:rPr lang="en-US" smtClean="0"/>
-              <a:t>10/13/2025</a:t>
+              <a:t>10/4/26</a:t>
             </a:fld>
             <a:endParaRPr lang="en-US"/>
           </a:p>
@@ -2492,7 +2492,7 @@
           <a:p>
             <a:fld id="{ACF36A98-F08A-4CFD-BE0D-05F2CBB67E88}" type="datetimeFigureOut">
               <a:rPr lang="en-US" smtClean="0"/>
-              <a:t>10/13/2025</a:t>
+              <a:t>10/4/26</a:t>
             </a:fld>
             <a:endParaRPr lang="en-US"/>
           </a:p>
@@ -2769,7 +2769,7 @@
           <a:p>
             <a:fld id="{ACF36A98-F08A-4CFD-BE0D-05F2CBB67E88}" type="datetimeFigureOut">
               <a:rPr lang="en-US" smtClean="0"/>
-              <a:t>10/13/2025</a:t>
+              <a:t>10/4/26</a:t>
             </a:fld>
             <a:endParaRPr lang="en-US"/>
           </a:p>
@@ -3026,7 +3026,7 @@
           <a:p>
             <a:fld id="{ACF36A98-F08A-4CFD-BE0D-05F2CBB67E88}" type="datetimeFigureOut">
               <a:rPr lang="en-US" smtClean="0"/>
-              <a:t>10/13/2025</a:t>
+              <a:t>10/4/26</a:t>
             </a:fld>
             <a:endParaRPr lang="en-US"/>
           </a:p>
@@ -3239,7 +3239,7 @@
           <a:p>
             <a:fld id="{ACF36A98-F08A-4CFD-BE0D-05F2CBB67E88}" type="datetimeFigureOut">
               <a:rPr lang="en-US" smtClean="0"/>
-              <a:t>10/13/2025</a:t>
+              <a:t>10/4/26</a:t>
             </a:fld>
             <a:endParaRPr lang="en-US"/>
           </a:p>
@@ -3750,7 +3750,7 @@
             </a:br>
             <a:r>
               <a:rPr lang="en-US" sz="6600" b="1" dirty="0"/>
-              <a:t>Insurance Application on Tabular Data</a:t>
+              <a:t>in Insurance: Tabular Data Applications</a:t>
             </a:r>
             <a:endParaRPr lang="en-US" sz="6600" dirty="0"/>
           </a:p>
@@ -3838,103 +3838,103 @@
           <a:custGeom>
             <a:avLst/>
             <a:gdLst>
-              <a:gd name="connsiteX0" fmla="*/ 0 w 5410200"/>
-              <a:gd name="connsiteY0" fmla="*/ 0 h 18288"/>
-              <a:gd name="connsiteX1" fmla="*/ 568071 w 5410200"/>
-              <a:gd name="connsiteY1" fmla="*/ 0 h 18288"/>
-              <a:gd name="connsiteX2" fmla="*/ 1298448 w 5410200"/>
-              <a:gd name="connsiteY2" fmla="*/ 0 h 18288"/>
-              <a:gd name="connsiteX3" fmla="*/ 1920621 w 5410200"/>
-              <a:gd name="connsiteY3" fmla="*/ 0 h 18288"/>
-              <a:gd name="connsiteX4" fmla="*/ 2488692 w 5410200"/>
-              <a:gd name="connsiteY4" fmla="*/ 0 h 18288"/>
-              <a:gd name="connsiteX5" fmla="*/ 3219069 w 5410200"/>
-              <a:gd name="connsiteY5" fmla="*/ 0 h 18288"/>
-              <a:gd name="connsiteX6" fmla="*/ 3895344 w 5410200"/>
-              <a:gd name="connsiteY6" fmla="*/ 0 h 18288"/>
-              <a:gd name="connsiteX7" fmla="*/ 4571619 w 5410200"/>
-              <a:gd name="connsiteY7" fmla="*/ 0 h 18288"/>
-              <a:gd name="connsiteX8" fmla="*/ 5410200 w 5410200"/>
-              <a:gd name="connsiteY8" fmla="*/ 0 h 18288"/>
-              <a:gd name="connsiteX9" fmla="*/ 5410200 w 5410200"/>
-              <a:gd name="connsiteY9" fmla="*/ 18288 h 18288"/>
-              <a:gd name="connsiteX10" fmla="*/ 4842129 w 5410200"/>
-              <a:gd name="connsiteY10" fmla="*/ 18288 h 18288"/>
-              <a:gd name="connsiteX11" fmla="*/ 4328160 w 5410200"/>
-              <a:gd name="connsiteY11" fmla="*/ 18288 h 18288"/>
-              <a:gd name="connsiteX12" fmla="*/ 3597783 w 5410200"/>
-              <a:gd name="connsiteY12" fmla="*/ 18288 h 18288"/>
-              <a:gd name="connsiteX13" fmla="*/ 3029712 w 5410200"/>
-              <a:gd name="connsiteY13" fmla="*/ 18288 h 18288"/>
-              <a:gd name="connsiteX14" fmla="*/ 2299335 w 5410200"/>
-              <a:gd name="connsiteY14" fmla="*/ 18288 h 18288"/>
-              <a:gd name="connsiteX15" fmla="*/ 1514856 w 5410200"/>
-              <a:gd name="connsiteY15" fmla="*/ 18288 h 18288"/>
-              <a:gd name="connsiteX16" fmla="*/ 892683 w 5410200"/>
-              <a:gd name="connsiteY16" fmla="*/ 18288 h 18288"/>
-              <a:gd name="connsiteX17" fmla="*/ 0 w 5410200"/>
-              <a:gd name="connsiteY17" fmla="*/ 18288 h 18288"/>
-              <a:gd name="connsiteX18" fmla="*/ 0 w 5410200"/>
-              <a:gd name="connsiteY18" fmla="*/ 0 h 18288"/>
+              <a:gd name="csX0" fmla="*/ 0 w 5410200"/>
+              <a:gd name="csY0" fmla="*/ 0 h 18288"/>
+              <a:gd name="csX1" fmla="*/ 568071 w 5410200"/>
+              <a:gd name="csY1" fmla="*/ 0 h 18288"/>
+              <a:gd name="csX2" fmla="*/ 1298448 w 5410200"/>
+              <a:gd name="csY2" fmla="*/ 0 h 18288"/>
+              <a:gd name="csX3" fmla="*/ 1920621 w 5410200"/>
+              <a:gd name="csY3" fmla="*/ 0 h 18288"/>
+              <a:gd name="csX4" fmla="*/ 2488692 w 5410200"/>
+              <a:gd name="csY4" fmla="*/ 0 h 18288"/>
+              <a:gd name="csX5" fmla="*/ 3219069 w 5410200"/>
+              <a:gd name="csY5" fmla="*/ 0 h 18288"/>
+              <a:gd name="csX6" fmla="*/ 3895344 w 5410200"/>
+              <a:gd name="csY6" fmla="*/ 0 h 18288"/>
+              <a:gd name="csX7" fmla="*/ 4571619 w 5410200"/>
+              <a:gd name="csY7" fmla="*/ 0 h 18288"/>
+              <a:gd name="csX8" fmla="*/ 5410200 w 5410200"/>
+              <a:gd name="csY8" fmla="*/ 0 h 18288"/>
+              <a:gd name="csX9" fmla="*/ 5410200 w 5410200"/>
+              <a:gd name="csY9" fmla="*/ 18288 h 18288"/>
+              <a:gd name="csX10" fmla="*/ 4842129 w 5410200"/>
+              <a:gd name="csY10" fmla="*/ 18288 h 18288"/>
+              <a:gd name="csX11" fmla="*/ 4328160 w 5410200"/>
+              <a:gd name="csY11" fmla="*/ 18288 h 18288"/>
+              <a:gd name="csX12" fmla="*/ 3597783 w 5410200"/>
+              <a:gd name="csY12" fmla="*/ 18288 h 18288"/>
+              <a:gd name="csX13" fmla="*/ 3029712 w 5410200"/>
+              <a:gd name="csY13" fmla="*/ 18288 h 18288"/>
+              <a:gd name="csX14" fmla="*/ 2299335 w 5410200"/>
+              <a:gd name="csY14" fmla="*/ 18288 h 18288"/>
+              <a:gd name="csX15" fmla="*/ 1514856 w 5410200"/>
+              <a:gd name="csY15" fmla="*/ 18288 h 18288"/>
+              <a:gd name="csX16" fmla="*/ 892683 w 5410200"/>
+              <a:gd name="csY16" fmla="*/ 18288 h 18288"/>
+              <a:gd name="csX17" fmla="*/ 0 w 5410200"/>
+              <a:gd name="csY17" fmla="*/ 18288 h 18288"/>
+              <a:gd name="csX18" fmla="*/ 0 w 5410200"/>
+              <a:gd name="csY18" fmla="*/ 0 h 18288"/>
             </a:gdLst>
             <a:ahLst/>
             <a:cxnLst>
               <a:cxn ang="0">
-                <a:pos x="connsiteX0" y="connsiteY0"/>
+                <a:pos x="csX0" y="csY0"/>
               </a:cxn>
               <a:cxn ang="0">
-                <a:pos x="connsiteX1" y="connsiteY1"/>
+                <a:pos x="csX1" y="csY1"/>
               </a:cxn>
               <a:cxn ang="0">
-                <a:pos x="connsiteX2" y="connsiteY2"/>
+                <a:pos x="csX2" y="csY2"/>
               </a:cxn>
               <a:cxn ang="0">
-                <a:pos x="connsiteX3" y="connsiteY3"/>
+                <a:pos x="csX3" y="csY3"/>
               </a:cxn>
               <a:cxn ang="0">
-                <a:pos x="connsiteX4" y="connsiteY4"/>
+                <a:pos x="csX4" y="csY4"/>
               </a:cxn>
               <a:cxn ang="0">
-                <a:pos x="connsiteX5" y="connsiteY5"/>
+                <a:pos x="csX5" y="csY5"/>
               </a:cxn>
               <a:cxn ang="0">
-                <a:pos x="connsiteX6" y="connsiteY6"/>
+                <a:pos x="csX6" y="csY6"/>
               </a:cxn>
               <a:cxn ang="0">
-                <a:pos x="connsiteX7" y="connsiteY7"/>
+                <a:pos x="csX7" y="csY7"/>
               </a:cxn>
               <a:cxn ang="0">
-                <a:pos x="connsiteX8" y="connsiteY8"/>
+                <a:pos x="csX8" y="csY8"/>
               </a:cxn>
               <a:cxn ang="0">
-                <a:pos x="connsiteX9" y="connsiteY9"/>
+                <a:pos x="csX9" y="csY9"/>
               </a:cxn>
               <a:cxn ang="0">
-                <a:pos x="connsiteX10" y="connsiteY10"/>
+                <a:pos x="csX10" y="csY10"/>
               </a:cxn>
               <a:cxn ang="0">
-                <a:pos x="connsiteX11" y="connsiteY11"/>
+                <a:pos x="csX11" y="csY11"/>
               </a:cxn>
               <a:cxn ang="0">
-                <a:pos x="connsiteX12" y="connsiteY12"/>
+                <a:pos x="csX12" y="csY12"/>
               </a:cxn>
               <a:cxn ang="0">
-                <a:pos x="connsiteX13" y="connsiteY13"/>
+                <a:pos x="csX13" y="csY13"/>
               </a:cxn>
               <a:cxn ang="0">
-                <a:pos x="connsiteX14" y="connsiteY14"/>
+                <a:pos x="csX14" y="csY14"/>
               </a:cxn>
               <a:cxn ang="0">
-                <a:pos x="connsiteX15" y="connsiteY15"/>
+                <a:pos x="csX15" y="csY15"/>
               </a:cxn>
               <a:cxn ang="0">
-                <a:pos x="connsiteX16" y="connsiteY16"/>
+                <a:pos x="csX16" y="csY16"/>
               </a:cxn>
               <a:cxn ang="0">
-                <a:pos x="connsiteX17" y="connsiteY17"/>
+                <a:pos x="csX17" y="csY17"/>
               </a:cxn>
               <a:cxn ang="0">
-                <a:pos x="connsiteX18" y="connsiteY18"/>
+                <a:pos x="csX18" y="csY18"/>
               </a:cxn>
             </a:cxnLst>
             <a:rect l="l" t="t" r="r" b="b"/>
@@ -4436,7 +4436,7 @@
           <a:p>
             <a:r>
               <a:rPr lang="en-US" b="1" dirty="0"/>
-              <a:t>Some personal tips</a:t>
+              <a:t>Personal tips</a:t>
             </a:r>
           </a:p>
         </p:txBody>
@@ -4514,7 +4514,7 @@
             </a:pPr>
             <a:r>
               <a:rPr lang="en-US" sz="1800" dirty="0"/>
-              <a:t>Python / R / SAS / SQL</a:t>
+              <a:t>Programming: Python / R / SAS / SQL</a:t>
             </a:r>
           </a:p>
         </p:txBody>
@@ -4861,22 +4861,18 @@
               <a:buAutoNum type="arabicPeriod"/>
             </a:pPr>
             <a:r>
-              <a:rPr lang="en-US"/>
-              <a:t>Who are we</a:t>
-            </a:r>
-            <a:r>
               <a:rPr lang="en-US" dirty="0"/>
-              <a:t>? Data scientists </a:t>
+              <a:t>Who are we? Data scientists in insurance </a:t>
             </a:r>
             <a:r>
               <a:rPr lang="en-US" dirty="0">
                 <a:sym typeface="Wingdings" panose="05000000000000000000" pitchFamily="2" charset="2"/>
               </a:rPr>
-              <a:t> Advanced Analytics  </a:t>
+              <a:t>(e.g., Advanced Analytics  </a:t>
             </a:r>
             <a:r>
               <a:rPr lang="en-US" dirty="0"/>
-              <a:t>Chief Data Office</a:t>
+              <a:t>Chief Data Office)</a:t>
             </a:r>
           </a:p>
           <a:p>
@@ -4891,7 +4887,7 @@
               <a:rPr lang="en-US" dirty="0">
                 <a:sym typeface="Wingdings" panose="05000000000000000000" pitchFamily="2" charset="2"/>
               </a:rPr>
-              <a:t>What is our value? Help other divisions – Underwriting, Claims, Actual Pricing, Sales and Marketing</a:t>
+              <a:t>What is our value? We help other divisions (Underwriting, Claims, Actuarial Pricing, Sales, Marketing) to:</a:t>
             </a:r>
           </a:p>
           <a:p>
@@ -4960,7 +4956,7 @@
               <a:rPr lang="en-US" dirty="0">
                 <a:sym typeface="Wingdings" panose="05000000000000000000" pitchFamily="2" charset="2"/>
               </a:rPr>
-              <a:t>What are our deliveries?</a:t>
+              <a:t>What do we deliver?</a:t>
             </a:r>
           </a:p>
           <a:p>
@@ -4972,7 +4968,7 @@
               <a:rPr lang="en-US" dirty="0">
                 <a:sym typeface="Wingdings" panose="05000000000000000000" pitchFamily="2" charset="2"/>
               </a:rPr>
-              <a:t>Models: Pricing/rating model, rating selection model, submission prioritization/triage model (smart renewal model), claim reserve model, claim triage model, claim life circle model, fraud model, litigation potential detection, …</a:t>
+              <a:t>Models: Pricing/rating, rating selection, submission prioritization/triage (smart renewal), claim reserving, claim triage, claim lifecycle, fraud, litigation potential detection, …</a:t>
             </a:r>
           </a:p>
           <a:p>
@@ -4984,7 +4980,7 @@
               <a:rPr lang="en-US" dirty="0">
                 <a:sym typeface="Wingdings" panose="05000000000000000000" pitchFamily="2" charset="2"/>
               </a:rPr>
-              <a:t>Apps: Pattern mining, document extraction, document summarization, document chat, …</a:t>
+              <a:t>Apps: Pattern mining, document extraction, summarization and chat, …</a:t>
             </a:r>
           </a:p>
           <a:p>
@@ -4996,7 +4992,7 @@
               <a:rPr lang="en-US" dirty="0">
                 <a:sym typeface="Wingdings" panose="05000000000000000000" pitchFamily="2" charset="2"/>
               </a:rPr>
-              <a:t>Dashboards</a:t>
+              <a:t>Dashboards – More focus on data analysis</a:t>
             </a:r>
           </a:p>
           <a:p>
@@ -5008,7 +5004,7 @@
               <a:rPr lang="en-US" dirty="0">
                 <a:sym typeface="Wingdings" panose="05000000000000000000" pitchFamily="2" charset="2"/>
               </a:rPr>
-              <a:t>Data pipelines</a:t>
+              <a:t>Data pipelines – More focus on data engineering</a:t>
             </a:r>
           </a:p>
           <a:p>
@@ -5432,10 +5428,14 @@
                 <a:latin typeface="Calibri" panose="020F0502020204030204" pitchFamily="34" charset="0"/>
                 <a:cs typeface="Calibri" panose="020F0502020204030204" pitchFamily="34" charset="0"/>
               </a:rPr>
-              <a:t>Recap business problem</a:t>
-            </a:r>
-          </a:p>
-          <a:p>
+              <a:t>Define the modeling objective</a:t>
+            </a:r>
+          </a:p>
+          <a:p>
+            <a:pPr marL="285750" indent="-285750">
+              <a:buFont typeface="Wingdings" panose="05000000000000000000" pitchFamily="2" charset="2"/>
+              <a:buChar char="v"/>
+            </a:pPr>
             <a:endParaRPr lang="en-US" sz="1400" dirty="0">
               <a:solidFill>
                 <a:sysClr val="windowText" lastClr="000000"/>
@@ -5458,6 +5458,31 @@
                 <a:cs typeface="Calibri" panose="020F0502020204030204" pitchFamily="34" charset="0"/>
               </a:rPr>
               <a:t>Decide model structure</a:t>
+            </a:r>
+          </a:p>
+          <a:p>
+            <a:endParaRPr lang="en-US" sz="1400" dirty="0">
+              <a:solidFill>
+                <a:sysClr val="windowText" lastClr="000000"/>
+              </a:solidFill>
+              <a:latin typeface="Calibri" panose="020F0502020204030204" pitchFamily="34" charset="0"/>
+              <a:cs typeface="Calibri" panose="020F0502020204030204" pitchFamily="34" charset="0"/>
+            </a:endParaRPr>
+          </a:p>
+          <a:p>
+            <a:pPr marL="285750" indent="-285750">
+              <a:buFont typeface="Wingdings" panose="05000000000000000000" pitchFamily="2" charset="2"/>
+              <a:buChar char="v"/>
+            </a:pPr>
+            <a:r>
+              <a:rPr lang="en-US" sz="1400" dirty="0">
+                <a:solidFill>
+                  <a:sysClr val="windowText" lastClr="000000"/>
+                </a:solidFill>
+                <a:latin typeface="Calibri" panose="020F0502020204030204" pitchFamily="34" charset="0"/>
+                <a:cs typeface="Calibri" panose="020F0502020204030204" pitchFamily="34" charset="0"/>
+              </a:rPr>
+              <a:t>Early experiments</a:t>
             </a:r>
           </a:p>
           <a:p>
@@ -5526,7 +5551,7 @@
                 <a:latin typeface="Calibri" panose="020F0502020204030204" pitchFamily="34" charset="0"/>
                 <a:cs typeface="Calibri" panose="020F0502020204030204" pitchFamily="34" charset="0"/>
               </a:rPr>
-              <a:t>Collect data from internal and 3</a:t>
+              <a:t>Collect data from internal and third</a:t>
             </a:r>
             <a:r>
               <a:rPr lang="en-US" sz="1400" baseline="30000" dirty="0">
@@ -5536,7 +5561,7 @@
                 <a:latin typeface="Calibri" panose="020F0502020204030204" pitchFamily="34" charset="0"/>
                 <a:cs typeface="Calibri" panose="020F0502020204030204" pitchFamily="34" charset="0"/>
               </a:rPr>
-              <a:t>rd</a:t>
+              <a:t/>
             </a:r>
             <a:r>
               <a:rPr lang="en-US" sz="1400" dirty="0">
@@ -5546,7 +5571,7 @@
                 <a:latin typeface="Calibri" panose="020F0502020204030204" pitchFamily="34" charset="0"/>
                 <a:cs typeface="Calibri" panose="020F0502020204030204" pitchFamily="34" charset="0"/>
               </a:rPr>
-              <a:t> party sources</a:t>
+              <a:t>-party sources</a:t>
             </a:r>
           </a:p>
           <a:p>
@@ -5718,7 +5743,7 @@
                 <a:latin typeface="Calibri" panose="020F0502020204030204" pitchFamily="34" charset="0"/>
                 <a:cs typeface="Calibri" panose="020F0502020204030204" pitchFamily="34" charset="0"/>
               </a:rPr>
-              <a:t>Fine tune model – Hyper-parameter tuning</a:t>
+              <a:t>Fine-tune model – Hyperparameter tuning</a:t>
             </a:r>
           </a:p>
           <a:p>
@@ -5812,7 +5837,7 @@
                 <a:latin typeface="Calibri" panose="020F0502020204030204" pitchFamily="34" charset="0"/>
                 <a:cs typeface="Calibri" panose="020F0502020204030204" pitchFamily="34" charset="0"/>
               </a:rPr>
-              <a:t>Help deploy and maintain model in production</a:t>
+              <a:t>Deploy and maintain model in production</a:t>
             </a:r>
           </a:p>
           <a:p>
@@ -5841,14 +5866,10 @@
                 <a:latin typeface="Calibri" panose="020F0502020204030204" pitchFamily="34" charset="0"/>
                 <a:cs typeface="Calibri" panose="020F0502020204030204" pitchFamily="34" charset="0"/>
               </a:rPr>
-              <a:t>Help generate explainable predictions on new, unseen data</a:t>
-            </a:r>
-          </a:p>
-          <a:p>
-            <a:pPr marL="285750" indent="-285750">
-              <a:buFont typeface="Wingdings" panose="05000000000000000000" pitchFamily="2" charset="2"/>
-              <a:buChar char="v"/>
-            </a:pPr>
+              <a:t>Deliver model</a:t>
+            </a:r>
+          </a:p>
+          <a:p>
             <a:endParaRPr lang="en-US" sz="1400" dirty="0">
               <a:solidFill>
                 <a:schemeClr val="tx1"/>
@@ -5870,8 +5891,17 @@
                 <a:latin typeface="Calibri" panose="020F0502020204030204" pitchFamily="34" charset="0"/>
                 <a:cs typeface="Calibri" panose="020F0502020204030204" pitchFamily="34" charset="0"/>
               </a:rPr>
-              <a:t>Provide training for model users</a:t>
-            </a:r>
+              <a:t>Track model performance</a:t>
+            </a:r>
+          </a:p>
+          <a:p>
+            <a:endParaRPr lang="en-US" sz="1400" dirty="0">
+              <a:solidFill>
+                <a:schemeClr val="tx1"/>
+              </a:solidFill>
+              <a:latin typeface="Calibri" panose="020F0502020204030204" pitchFamily="34" charset="0"/>
+              <a:cs typeface="Calibri" panose="020F0502020204030204" pitchFamily="34" charset="0"/>
+            </a:endParaRPr>
           </a:p>
           <a:p>
             <a:endParaRPr lang="en-US" sz="1467" dirty="0">
@@ -6027,7 +6057,7 @@
                 <a:latin typeface="Calibri" panose="020F0502020204030204" pitchFamily="34" charset="0"/>
                 <a:cs typeface="Calibri" panose="020F0502020204030204" pitchFamily="34" charset="0"/>
               </a:rPr>
-              <a:t>Perform missing value imputation, variable transformation, stability check, predictiveness check, etc.</a:t>
+              <a:t>Handle missing values, transform variables, check stability and predictiveness, etc.</a:t>
             </a:r>
           </a:p>
           <a:p>
@@ -6525,7 +6555,7 @@
           <a:p>
             <a:r>
               <a:rPr lang="en-US" sz="3600" b="1" dirty="0"/>
-              <a:t>Model Design</a:t>
+              <a:t>Step 1: Model Design</a:t>
             </a:r>
           </a:p>
         </p:txBody>
@@ -6685,7 +6715,7 @@
                   <a:schemeClr val="bg1"/>
                 </a:solidFill>
               </a:rPr>
-              <a:t>Pol effective date</a:t>
+              <a:t>Policy effective date</a:t>
             </a:r>
           </a:p>
         </p:txBody>
@@ -6788,7 +6818,7 @@
                   <a:schemeClr val="bg1"/>
                 </a:solidFill>
               </a:rPr>
-              <a:t>Pol expiration date</a:t>
+              <a:t>Policy expiration date</a:t>
             </a:r>
           </a:p>
         </p:txBody>
@@ -7040,7 +7070,7 @@
                   <a:schemeClr val="tx1"/>
                 </a:solidFill>
               </a:rPr>
-              <a:t>Claim severity given a claim happens</a:t>
+              <a:t>Claim severity (given a claim)</a:t>
             </a:r>
           </a:p>
         </p:txBody>
@@ -7097,7 +7127,7 @@
                   <a:schemeClr val="tx1"/>
                 </a:solidFill>
               </a:rPr>
-              <a:t>Claim Frequency</a:t>
+              <a:t>Claim frequency</a:t>
             </a:r>
           </a:p>
         </p:txBody>
@@ -7302,7 +7332,7 @@
           <a:p>
             <a:r>
               <a:rPr lang="en-US" sz="1400" dirty="0"/>
-              <a:t>Target potential customers with low risk</a:t>
+              <a:t>Target low-risk potential customers</a:t>
             </a:r>
           </a:p>
           <a:p>
@@ -7607,13 +7637,13 @@
             </a:pPr>
             <a:r>
               <a:rPr lang="en-US" sz="1800" dirty="0"/>
-              <a:t>SQL server | Alteryx | Tableau | R shiny</a:t>
+              <a:t>Tools: SQL Server | Alteryx | Tableau | R Shiny</a:t>
             </a:r>
           </a:p>
           <a:p>
             <a:r>
               <a:rPr lang="en-US" sz="1800" dirty="0"/>
-              <a:t>A lot of external data sources nowadays</a:t>
+              <a:t>Many external data sources are now available</a:t>
             </a:r>
           </a:p>
           <a:p>
@@ -7732,7 +7762,7 @@
                 <a:latin typeface="Calibri" panose="020F0502020204030204" pitchFamily="34" charset="0"/>
                 <a:cs typeface="Calibri" panose="020F0502020204030204" pitchFamily="34" charset="0"/>
               </a:rPr>
-              <a:t>Vehicle related:</a:t>
+              <a:t>Vehicle:</a:t>
             </a:r>
           </a:p>
           <a:p>
@@ -7801,7 +7831,7 @@
                 <a:latin typeface="Calibri" panose="020F0502020204030204" pitchFamily="34" charset="0"/>
                 <a:cs typeface="Calibri" panose="020F0502020204030204" pitchFamily="34" charset="0"/>
               </a:rPr>
-              <a:t>Policy related:</a:t>
+              <a:t>Claim history:</a:t>
             </a:r>
           </a:p>
           <a:p>
@@ -7938,7 +7968,7 @@
                 <a:latin typeface="Calibri" panose="020F0502020204030204" pitchFamily="34" charset="0"/>
                 <a:cs typeface="Calibri" panose="020F0502020204030204" pitchFamily="34" charset="0"/>
               </a:rPr>
-              <a:t>US census:</a:t>
+              <a:t>US Census:</a:t>
             </a:r>
           </a:p>
           <a:p>
@@ -7962,7 +7992,7 @@
                 <a:latin typeface="Calibri" panose="020F0502020204030204" pitchFamily="34" charset="0"/>
                 <a:cs typeface="Calibri" panose="020F0502020204030204" pitchFamily="34" charset="0"/>
               </a:rPr>
-              <a:t>– house unit</a:t>
+              <a:t>– housing units</a:t>
             </a:r>
           </a:p>
           <a:p>
@@ -7995,7 +8025,7 @@
                 <a:latin typeface="Calibri" panose="020F0502020204030204" pitchFamily="34" charset="0"/>
                 <a:cs typeface="Calibri" panose="020F0502020204030204" pitchFamily="34" charset="0"/>
               </a:rPr>
-              <a:t>– # of hit-run crimes</a:t>
+              <a:t>– # of hit-and-run crimes</a:t>
             </a:r>
           </a:p>
           <a:p>
@@ -8028,7 +8058,7 @@
                 <a:latin typeface="Calibri" panose="020F0502020204030204" pitchFamily="34" charset="0"/>
                 <a:cs typeface="Calibri" panose="020F0502020204030204" pitchFamily="34" charset="0"/>
               </a:rPr>
-              <a:t>FARS:</a:t>
+              <a:t>NHTSA FARS:</a:t>
             </a:r>
           </a:p>
           <a:p>
@@ -8040,7 +8070,7 @@
                 <a:latin typeface="Calibri" panose="020F0502020204030204" pitchFamily="34" charset="0"/>
                 <a:cs typeface="Calibri" panose="020F0502020204030204" pitchFamily="34" charset="0"/>
               </a:rPr>
-              <a:t>– # of fatal crashes </a:t>
+              <a:t>– # of fatal crashes</a:t>
             </a:r>
           </a:p>
         </p:txBody>
@@ -8104,6 +8134,137 @@
       </p:sp>
       <p:sp>
         <p:nvSpPr>
+          <p:cNvPr id="13" name="Rectangle 12"/>
+          <p:cNvSpPr/>
+          <p:nvPr/>
+        </p:nvSpPr>
+        <p:spPr>
+          <a:xfrm>
+            <a:off x="5851859" y="3668942"/>
+            <a:ext cx="1575048" cy="2997424"/>
+          </a:xfrm>
+          <a:prstGeom prst="rect">
+            <a:avLst/>
+          </a:prstGeom>
+          <a:ln w="28575">
+            <a:headEnd type="none" w="med" len="med"/>
+            <a:tailEnd type="none" w="med" len="med"/>
+          </a:ln>
+        </p:spPr>
+        <p:style>
+          <a:lnRef idx="2">
+            <a:schemeClr val="accent1"/>
+          </a:lnRef>
+          <a:fillRef idx="1">
+            <a:schemeClr val="lt1"/>
+          </a:fillRef>
+          <a:effectRef idx="0">
+            <a:schemeClr val="accent1"/>
+          </a:effectRef>
+          <a:fontRef idx="minor">
+            <a:schemeClr val="dk1"/>
+          </a:fontRef>
+        </p:style>
+        <p:txBody>
+          <a:bodyPr rtlCol="0" anchor="t"/>
+          <a:lstStyle/>
+          <a:p>
+            <a:r>
+              <a:rPr lang="en-US" sz="1400" dirty="0">
+                <a:solidFill>
+                  <a:sysClr val="windowText" lastClr="000000"/>
+                </a:solidFill>
+                <a:latin typeface="Calibri" panose="020F0502020204030204" pitchFamily="34" charset="0"/>
+                <a:cs typeface="Calibri" panose="020F0502020204030204" pitchFamily="34" charset="0"/>
+              </a:rPr>
+              <a:t>Climate:</a:t>
+            </a:r>
+          </a:p>
+          <a:p>
+            <a:r>
+              <a:rPr lang="en-US" sz="1400" dirty="0">
+                <a:solidFill>
+                  <a:sysClr val="windowText" lastClr="000000"/>
+                </a:solidFill>
+                <a:latin typeface="Calibri" panose="020F0502020204030204" pitchFamily="34" charset="0"/>
+                <a:cs typeface="Calibri" panose="020F0502020204030204" pitchFamily="34" charset="0"/>
+              </a:rPr>
+              <a:t>– average temperature</a:t>
+            </a:r>
+          </a:p>
+          <a:p>
+            <a:r>
+              <a:rPr lang="en-US" sz="1400" dirty="0">
+                <a:solidFill>
+                  <a:sysClr val="windowText" lastClr="000000"/>
+                </a:solidFill>
+                <a:latin typeface="Calibri" panose="020F0502020204030204" pitchFamily="34" charset="0"/>
+                <a:cs typeface="Calibri" panose="020F0502020204030204" pitchFamily="34" charset="0"/>
+              </a:rPr>
+              <a:t>– annual rainfall</a:t>
+            </a:r>
+          </a:p>
+          <a:p>
+            <a:r>
+              <a:rPr lang="en-US" sz="1400" dirty="0">
+                <a:solidFill>
+                  <a:sysClr val="windowText" lastClr="000000"/>
+                </a:solidFill>
+                <a:latin typeface="Calibri" panose="020F0502020204030204" pitchFamily="34" charset="0"/>
+                <a:cs typeface="Calibri" panose="020F0502020204030204" pitchFamily="34" charset="0"/>
+              </a:rPr>
+              <a:t>– distance to nearest water body</a:t>
+            </a:r>
+          </a:p>
+          <a:p>
+            <a:endParaRPr lang="en-US" sz="1400" dirty="0">
+              <a:solidFill>
+                <a:sysClr val="windowText" lastClr="000000"/>
+              </a:solidFill>
+              <a:latin typeface="Calibri" panose="020F0502020204030204" pitchFamily="34" charset="0"/>
+              <a:cs typeface="Calibri" panose="020F0502020204030204" pitchFamily="34" charset="0"/>
+            </a:endParaRPr>
+          </a:p>
+          <a:p>
+            <a:r>
+              <a:rPr lang="en-US" sz="1400" dirty="0">
+                <a:solidFill>
+                  <a:sysClr val="windowText" lastClr="000000"/>
+                </a:solidFill>
+                <a:latin typeface="Calibri" panose="020F0502020204030204" pitchFamily="34" charset="0"/>
+                <a:cs typeface="Calibri" panose="020F0502020204030204" pitchFamily="34" charset="0"/>
+              </a:rPr>
+              <a:t>Severe weather:</a:t>
+            </a:r>
+          </a:p>
+          <a:p>
+            <a:r>
+              <a:rPr lang="en-US" sz="1400" dirty="0">
+                <a:solidFill>
+                  <a:sysClr val="windowText" lastClr="000000"/>
+                </a:solidFill>
+                <a:latin typeface="Calibri" panose="020F0502020204030204" pitchFamily="34" charset="0"/>
+                <a:cs typeface="Calibri" panose="020F0502020204030204" pitchFamily="34" charset="0"/>
+              </a:rPr>
+              <a:t>– # of hail days per year</a:t>
+            </a:r>
+          </a:p>
+          <a:p>
+            <a:r>
+              <a:rPr lang="en-US" sz="1400" dirty="0">
+                <a:solidFill>
+                  <a:sysClr val="windowText" lastClr="000000"/>
+                </a:solidFill>
+                <a:latin typeface="Calibri" panose="020F0502020204030204" pitchFamily="34" charset="0"/>
+                <a:cs typeface="Calibri" panose="020F0502020204030204" pitchFamily="34" charset="0"/>
+              </a:rPr>
+              <a:t>– # of flood events</a:t>
+            </a:r>
+          </a:p>
+        </p:txBody>
+      </p:sp>
+      <p:sp>
+        <p:nvSpPr>
           <p:cNvPr id="12" name="Rectangle: Rounded Corners 11">
             <a:extLst>
               <a:ext uri="{FF2B5EF4-FFF2-40B4-BE49-F238E27FC236}">
@@ -8155,6 +8316,137 @@
                 </a:solidFill>
               </a:rPr>
               <a:t>Credit</a:t>
+            </a:r>
+          </a:p>
+        </p:txBody>
+      </p:sp>
+      <p:sp>
+        <p:nvSpPr>
+          <p:cNvPr id="14" name="Rectangle 13"/>
+          <p:cNvSpPr/>
+          <p:nvPr/>
+        </p:nvSpPr>
+        <p:spPr>
+          <a:xfrm>
+            <a:off x="8023187" y="3668942"/>
+            <a:ext cx="1575048" cy="2997424"/>
+          </a:xfrm>
+          <a:prstGeom prst="rect">
+            <a:avLst/>
+          </a:prstGeom>
+          <a:ln w="28575">
+            <a:headEnd type="none" w="med" len="med"/>
+            <a:tailEnd type="none" w="med" len="med"/>
+          </a:ln>
+        </p:spPr>
+        <p:style>
+          <a:lnRef idx="2">
+            <a:schemeClr val="accent1"/>
+          </a:lnRef>
+          <a:fillRef idx="1">
+            <a:schemeClr val="lt1"/>
+          </a:fillRef>
+          <a:effectRef idx="0">
+            <a:schemeClr val="accent1"/>
+          </a:effectRef>
+          <a:fontRef idx="minor">
+            <a:schemeClr val="dk1"/>
+          </a:fontRef>
+        </p:style>
+        <p:txBody>
+          <a:bodyPr rtlCol="0" anchor="t"/>
+          <a:lstStyle/>
+          <a:p>
+            <a:r>
+              <a:rPr lang="en-US" sz="1400" dirty="0">
+                <a:solidFill>
+                  <a:sysClr val="windowText" lastClr="000000"/>
+                </a:solidFill>
+                <a:latin typeface="Calibri" panose="020F0502020204030204" pitchFamily="34" charset="0"/>
+                <a:cs typeface="Calibri" panose="020F0502020204030204" pitchFamily="34" charset="0"/>
+              </a:rPr>
+              <a:t>Financial credit:</a:t>
+            </a:r>
+          </a:p>
+          <a:p>
+            <a:r>
+              <a:rPr lang="en-US" sz="1400" dirty="0">
+                <a:solidFill>
+                  <a:sysClr val="windowText" lastClr="000000"/>
+                </a:solidFill>
+                <a:latin typeface="Calibri" panose="020F0502020204030204" pitchFamily="34" charset="0"/>
+                <a:cs typeface="Calibri" panose="020F0502020204030204" pitchFamily="34" charset="0"/>
+              </a:rPr>
+              <a:t>– credit score</a:t>
+            </a:r>
+          </a:p>
+          <a:p>
+            <a:r>
+              <a:rPr lang="en-US" sz="1400" dirty="0">
+                <a:solidFill>
+                  <a:sysClr val="windowText" lastClr="000000"/>
+                </a:solidFill>
+                <a:latin typeface="Calibri" panose="020F0502020204030204" pitchFamily="34" charset="0"/>
+                <a:cs typeface="Calibri" panose="020F0502020204030204" pitchFamily="34" charset="0"/>
+              </a:rPr>
+              <a:t>– # of late payments</a:t>
+            </a:r>
+          </a:p>
+          <a:p>
+            <a:r>
+              <a:rPr lang="en-US" sz="1400" dirty="0">
+                <a:solidFill>
+                  <a:sysClr val="windowText" lastClr="000000"/>
+                </a:solidFill>
+                <a:latin typeface="Calibri" panose="020F0502020204030204" pitchFamily="34" charset="0"/>
+                <a:cs typeface="Calibri" panose="020F0502020204030204" pitchFamily="34" charset="0"/>
+              </a:rPr>
+              <a:t>– credit utilization (% of limit)</a:t>
+            </a:r>
+          </a:p>
+          <a:p>
+            <a:endParaRPr lang="en-US" sz="1400" dirty="0">
+              <a:solidFill>
+                <a:sysClr val="windowText" lastClr="000000"/>
+              </a:solidFill>
+              <a:latin typeface="Calibri" panose="020F0502020204030204" pitchFamily="34" charset="0"/>
+              <a:cs typeface="Calibri" panose="020F0502020204030204" pitchFamily="34" charset="0"/>
+            </a:endParaRPr>
+          </a:p>
+          <a:p>
+            <a:r>
+              <a:rPr lang="en-US" sz="1400" dirty="0">
+                <a:solidFill>
+                  <a:sysClr val="windowText" lastClr="000000"/>
+                </a:solidFill>
+                <a:latin typeface="Calibri" panose="020F0502020204030204" pitchFamily="34" charset="0"/>
+                <a:cs typeface="Calibri" panose="020F0502020204030204" pitchFamily="34" charset="0"/>
+              </a:rPr>
+              <a:t>Credit history:</a:t>
+            </a:r>
+          </a:p>
+          <a:p>
+            <a:r>
+              <a:rPr lang="en-US" sz="1400" dirty="0">
+                <a:solidFill>
+                  <a:sysClr val="windowText" lastClr="000000"/>
+                </a:solidFill>
+                <a:latin typeface="Calibri" panose="020F0502020204030204" pitchFamily="34" charset="0"/>
+                <a:cs typeface="Calibri" panose="020F0502020204030204" pitchFamily="34" charset="0"/>
+              </a:rPr>
+              <a:t>– years of credit history</a:t>
+            </a:r>
+          </a:p>
+          <a:p>
+            <a:r>
+              <a:rPr lang="en-US" sz="1400" dirty="0">
+                <a:solidFill>
+                  <a:sysClr val="windowText" lastClr="000000"/>
+                </a:solidFill>
+                <a:latin typeface="Calibri" panose="020F0502020204030204" pitchFamily="34" charset="0"/>
+                <a:cs typeface="Calibri" panose="020F0502020204030204" pitchFamily="34" charset="0"/>
+              </a:rPr>
+              <a:t>– # of recent credit inquiries</a:t>
             </a:r>
           </a:p>
         </p:txBody>
@@ -8836,7 +9128,7 @@
                           <a:ea typeface="+mn-ea"/>
                           <a:cs typeface="Calibri" panose="020F0502020204030204" pitchFamily="34" charset="0"/>
                         </a:rPr>
-                        <a:t>Training frame -&gt; Fit model</a:t>
+                        <a:t>Training frame → fit model</a:t>
                       </a:r>
                     </a:p>
                     <a:p>
@@ -8866,7 +9158,7 @@
                           <a:ea typeface="+mn-ea"/>
                           <a:cs typeface="Calibri" panose="020F0502020204030204" pitchFamily="34" charset="0"/>
                         </a:rPr>
-                        <a:t>(Out-of-time) hold-out frame </a:t>
+                        <a:t>(Out-of-time) hold-out frame</a:t>
                       </a:r>
                     </a:p>
                     <a:p>
@@ -8896,7 +9188,7 @@
                           <a:ea typeface="+mn-ea"/>
                           <a:cs typeface="Calibri" panose="020F0502020204030204" pitchFamily="34" charset="0"/>
                         </a:rPr>
-                        <a:t>-&gt; Test model performance</a:t>
+                        <a:t>→ test model performance</a:t>
                       </a:r>
                     </a:p>
                   </a:txBody>
@@ -9071,7 +9363,7 @@
                           <a:ea typeface="+mn-ea"/>
                           <a:cs typeface="Calibri" panose="020F0502020204030204" pitchFamily="34" charset="0"/>
                         </a:rPr>
-                        <a:t>Predictor vs target </a:t>
+                        <a:t>Predictor vs target</a:t>
                       </a:r>
                     </a:p>
                     <a:p>
@@ -9275,13 +9567,13 @@
             <a:avLst/>
           </a:prstGeom>
           <a:blipFill>
-            <a:blip r:embed="rId2">
+            <a:blip>
               <a:extLst>
                 <a:ext uri="{28A0092B-C50C-407E-A947-70E740481C1C}">
                   <a14:useLocalDpi xmlns:a14="http://schemas.microsoft.com/office/drawing/2010/main" val="0"/>
                 </a:ext>
                 <a:ext uri="{96DAC541-7B7A-43D3-8B79-37D633B846F1}">
-                  <asvg:svgBlip xmlns:asvg="http://schemas.microsoft.com/office/drawing/2016/SVG/main" r:embed="rId3"/>
+                  <asvg:svgBlip xmlns:asvg="http://schemas.microsoft.com/office/drawing/2016/SVG/main" r:embed="rId2"/>
                 </a:ext>
               </a:extLst>
             </a:blip>
@@ -9341,7 +9633,7 @@
             <a:avLst/>
           </a:prstGeom>
           <a:blipFill rotWithShape="1">
-            <a:blip r:embed="rId4"/>
+            <a:blip r:embed="rId3"/>
             <a:srcRect/>
             <a:stretch>
               <a:fillRect l="-1000" r="-1000"/>
@@ -9399,13 +9691,13 @@
             <a:avLst/>
           </a:prstGeom>
           <a:blipFill>
-            <a:blip r:embed="rId5">
+            <a:blip>
               <a:extLst>
                 <a:ext uri="{28A0092B-C50C-407E-A947-70E740481C1C}">
                   <a14:useLocalDpi xmlns:a14="http://schemas.microsoft.com/office/drawing/2010/main" val="0"/>
                 </a:ext>
                 <a:ext uri="{96DAC541-7B7A-43D3-8B79-37D633B846F1}">
-                  <asvg:svgBlip xmlns:asvg="http://schemas.microsoft.com/office/drawing/2016/SVG/main" r:embed="rId6"/>
+                  <asvg:svgBlip xmlns:asvg="http://schemas.microsoft.com/office/drawing/2016/SVG/main" r:embed="rId4"/>
                 </a:ext>
               </a:extLst>
             </a:blip>
@@ -9595,11 +9887,12 @@
                     <m:sSub>
                       <m:sSubPr>
                         <m:ctrlPr>
-                          <a:rPr lang="en-US" sz="1800" i="1" smtClean="0">
+                          <a:rPr lang="en-US" sz="1800" b="0" i="1" smtClean="0">
                             <a:solidFill>
                               <a:schemeClr val="tx1"/>
                             </a:solidFill>
                             <a:latin typeface="Cambria Math" panose="02040503050406030204" pitchFamily="18" charset="0"/>
+                            <a:ea typeface="Cambria Math" panose="02040503050406030204" pitchFamily="18" charset="0"/>
                             <a:cs typeface="Calibri" panose="020F0502020204030204" pitchFamily="34" charset="0"/>
                           </a:rPr>
                         </m:ctrlPr>
@@ -9643,11 +9936,12 @@
                     <m:sSub>
                       <m:sSubPr>
                         <m:ctrlPr>
-                          <a:rPr lang="en-US" sz="1800" i="1" smtClean="0">
+                          <a:rPr lang="en-US" sz="1800" b="0" i="1" smtClean="0">
                             <a:solidFill>
                               <a:schemeClr val="tx1"/>
                             </a:solidFill>
                             <a:latin typeface="Cambria Math" panose="02040503050406030204" pitchFamily="18" charset="0"/>
+                            <a:ea typeface="Cambria Math" panose="02040503050406030204" pitchFamily="18" charset="0"/>
                             <a:cs typeface="Calibri" panose="020F0502020204030204" pitchFamily="34" charset="0"/>
                           </a:rPr>
                         </m:ctrlPr>
@@ -9681,7 +9975,7 @@
                     <m:sSub>
                       <m:sSubPr>
                         <m:ctrlPr>
-                          <a:rPr lang="en-US" sz="1800" i="1" smtClean="0">
+                          <a:rPr lang="en-US" sz="1800" b="0" i="1" smtClean="0">
                             <a:solidFill>
                               <a:schemeClr val="tx1"/>
                             </a:solidFill>
@@ -9739,8 +10033,9 @@
                     <m:sSub>
                       <m:sSubPr>
                         <m:ctrlPr>
-                          <a:rPr lang="en-US" sz="1800" i="1">
+                          <a:rPr lang="en-US" sz="1800" b="0" i="1">
                             <a:latin typeface="Cambria Math" panose="02040503050406030204" pitchFamily="18" charset="0"/>
+                            <a:ea typeface="Cambria Math" panose="02040503050406030204" pitchFamily="18" charset="0"/>
                             <a:cs typeface="Calibri" panose="020F0502020204030204" pitchFamily="34" charset="0"/>
                           </a:rPr>
                         </m:ctrlPr>
@@ -9769,7 +10064,7 @@
                     <m:sSub>
                       <m:sSubPr>
                         <m:ctrlPr>
-                          <a:rPr lang="en-US" sz="1800" i="1">
+                          <a:rPr lang="en-US" sz="1800" b="0" i="1">
                             <a:latin typeface="Cambria Math" panose="02040503050406030204" pitchFamily="18" charset="0"/>
                             <a:cs typeface="Calibri" panose="020F0502020204030204" pitchFamily="34" charset="0"/>
                           </a:rPr>
@@ -9827,7 +10122,7 @@
                   <a:rPr lang="en-US" sz="1800" dirty="0">
                     <a:cs typeface="Calibri" panose="020F0502020204030204" pitchFamily="34" charset="0"/>
                   </a:rPr>
-                  <a:t>Decision Tree </a:t>
+                  <a:t>Decision Tree</a:t>
                 </a:r>
               </a:p>
               <a:p>
@@ -9836,7 +10131,7 @@
                   <a:rPr lang="en-US" sz="1800" dirty="0">
                     <a:cs typeface="Calibri" panose="020F0502020204030204" pitchFamily="34" charset="0"/>
                   </a:rPr>
-                  <a:t>Ensemble Tree </a:t>
+                  <a:t>Ensemble Tree</a:t>
                 </a:r>
               </a:p>
               <a:p>
@@ -9859,7 +10154,7 @@
                     </a:solidFill>
                     <a:cs typeface="Calibri" panose="020F0502020204030204" pitchFamily="34" charset="0"/>
                   </a:rPr>
-                  <a:t>Random Forest </a:t>
+                  <a:t>Random Forest</a:t>
                 </a:r>
               </a:p>
               <a:p>
@@ -9901,7 +10196,7 @@
                   <a:rPr lang="en-US" sz="1800" b="1" dirty="0">
                     <a:cs typeface="Calibri" panose="020F0502020204030204" pitchFamily="34" charset="0"/>
                   </a:rPr>
-                  <a:t>Fine tune model</a:t>
+                  <a:t>Fine-tune model</a:t>
                 </a:r>
               </a:p>
               <a:p>
@@ -10083,7 +10378,7 @@
           <a:p>
             <a:r>
               <a:rPr lang="en-US" b="1" dirty="0"/>
-              <a:t>Different Modeling Techniques Comparison</a:t>
+              <a:t>Modeling Techniques Comparison</a:t>
             </a:r>
           </a:p>
         </p:txBody>
@@ -10221,7 +10516,7 @@
               <a:rPr lang="en-US" altLang="zh-CN" sz="1400" dirty="0">
                 <a:cs typeface="Calibri" panose="020F0502020204030204" pitchFamily="34" charset="0"/>
               </a:rPr>
-              <a:t>price</a:t>
+              <a:t>Price</a:t>
             </a:r>
             <a:r>
               <a:rPr lang="zh-CN" altLang="en-US" sz="1400" dirty="0">
@@ -10233,7 +10528,7 @@
               <a:rPr lang="en-US" altLang="zh-CN" sz="1400" dirty="0">
                 <a:cs typeface="Calibri" panose="020F0502020204030204" pitchFamily="34" charset="0"/>
               </a:rPr>
-              <a:t>new/return</a:t>
+              <a:t>new/renewal</a:t>
             </a:r>
             <a:r>
               <a:rPr lang="zh-CN" altLang="en-US" sz="1400" dirty="0">
@@ -10247,23 +10542,29 @@
               </a:rPr>
               <a:t>policies</a:t>
             </a:r>
+            <a:endParaRPr lang="en-US" altLang="zh-CN" sz="1400" dirty="0">
+              <a:cs typeface="Calibri" panose="020F0502020204030204" pitchFamily="34" charset="0"/>
+            </a:endParaRPr>
+          </a:p>
+          <a:p>
+            <a:pPr lvl="1"/>
+            <a:r>
+              <a:rPr lang="en-US" altLang="zh-CN" sz="1400" dirty="0">
+                <a:cs typeface="Calibri" panose="020F0502020204030204" pitchFamily="34" charset="0"/>
+              </a:rPr>
+              <a:t>Explain</a:t>
+            </a:r>
             <a:r>
               <a:rPr lang="zh-CN" altLang="en-US" sz="1400" dirty="0">
                 <a:cs typeface="Calibri" panose="020F0502020204030204" pitchFamily="34" charset="0"/>
               </a:rPr>
               <a:t> </a:t>
             </a:r>
-            <a:endParaRPr lang="en-US" altLang="zh-CN" sz="1400" dirty="0">
-              <a:cs typeface="Calibri" panose="020F0502020204030204" pitchFamily="34" charset="0"/>
-            </a:endParaRPr>
-          </a:p>
-          <a:p>
-            <a:pPr lvl="1"/>
             <a:r>
               <a:rPr lang="en-US" altLang="zh-CN" sz="1400" dirty="0">
                 <a:cs typeface="Calibri" panose="020F0502020204030204" pitchFamily="34" charset="0"/>
               </a:rPr>
-              <a:t>give</a:t>
+              <a:t>premium</a:t>
             </a:r>
             <a:r>
               <a:rPr lang="zh-CN" altLang="en-US" sz="1400" dirty="0">
@@ -10275,52 +10576,40 @@
               <a:rPr lang="en-US" altLang="zh-CN" sz="1400" dirty="0">
                 <a:cs typeface="Calibri" panose="020F0502020204030204" pitchFamily="34" charset="0"/>
               </a:rPr>
-              <a:t>reason</a:t>
+              <a:t>changes</a:t>
             </a:r>
             <a:r>
               <a:rPr lang="zh-CN" altLang="en-US" sz="1400" dirty="0">
                 <a:cs typeface="Calibri" panose="020F0502020204030204" pitchFamily="34" charset="0"/>
               </a:rPr>
-              <a:t> </a:t>
+              <a:t/>
             </a:r>
             <a:r>
               <a:rPr lang="en-US" altLang="zh-CN" sz="1400" dirty="0">
                 <a:cs typeface="Calibri" panose="020F0502020204030204" pitchFamily="34" charset="0"/>
               </a:rPr>
-              <a:t>for</a:t>
+              <a:t/>
             </a:r>
             <a:r>
               <a:rPr lang="zh-CN" altLang="en-US" sz="1400" dirty="0">
                 <a:cs typeface="Calibri" panose="020F0502020204030204" pitchFamily="34" charset="0"/>
               </a:rPr>
-              <a:t> </a:t>
+              <a:t/>
             </a:r>
             <a:r>
               <a:rPr lang="en-US" altLang="zh-CN" sz="1400" dirty="0">
                 <a:cs typeface="Calibri" panose="020F0502020204030204" pitchFamily="34" charset="0"/>
               </a:rPr>
-              <a:t>premium</a:t>
-            </a:r>
-            <a:r>
-              <a:rPr lang="zh-CN" altLang="en-US" sz="1400" dirty="0">
-                <a:cs typeface="Calibri" panose="020F0502020204030204" pitchFamily="34" charset="0"/>
-              </a:rPr>
-              <a:t> </a:t>
-            </a:r>
+              <a:t/>
+            </a:r>
+          </a:p>
+          <a:p>
+            <a:pPr lvl="1"/>
             <a:r>
               <a:rPr lang="en-US" altLang="zh-CN" sz="1400" dirty="0">
                 <a:cs typeface="Calibri" panose="020F0502020204030204" pitchFamily="34" charset="0"/>
               </a:rPr>
-              <a:t>change </a:t>
-            </a:r>
-          </a:p>
-          <a:p>
-            <a:pPr lvl="1"/>
-            <a:r>
-              <a:rPr lang="en-US" altLang="zh-CN" sz="1400" dirty="0">
-                <a:cs typeface="Calibri" panose="020F0502020204030204" pitchFamily="34" charset="0"/>
-              </a:rPr>
-              <a:t>generate pricing report</a:t>
+              <a:t>Generate pricing reports</a:t>
             </a:r>
             <a:endParaRPr lang="en-US" sz="1400" dirty="0">
               <a:solidFill>
@@ -10372,7 +10661,7 @@
                 <a:latin typeface="Calibri" panose="020F0502020204030204" pitchFamily="34" charset="0"/>
                 <a:cs typeface="Calibri" panose="020F0502020204030204" pitchFamily="34" charset="0"/>
               </a:rPr>
-              <a:t>underwriting department</a:t>
+              <a:t>(e.g., underwriting department)</a:t>
             </a:r>
           </a:p>
           <a:p>
@@ -10393,7 +10682,7 @@
                 <a:latin typeface="Calibri" panose="020F0502020204030204" pitchFamily="34" charset="0"/>
                 <a:cs typeface="Calibri" panose="020F0502020204030204" pitchFamily="34" charset="0"/>
               </a:rPr>
-              <a:t>Analyze and trace model performance in analytical reports and dashboards </a:t>
+              <a:t>Track model performance in reports and dashboards</a:t>
             </a:r>
           </a:p>
           <a:p>

</xml_diff>